<commit_message>
chore: add demo video and slide-8 variant deck
Embeds the 30s screen-recording into slide 7 of the 7-minute deck and
adds the qualitative before/after variant of slide 8.

Co-Authored-By: Claude Opus 5 <noreply@anthropic.com>
</commit_message>
<xml_diff>
--- a/presentation-output/FUTURE_M_RADAR_7분발표.pptx
+++ b/presentation-output/FUTURE_M_RADAR_7분발표.pptx
@@ -1154,11 +1154,12 @@
           <a:p>
             <a:r>
               <a:rPr lang="en-US" dirty="0"/>
-              <a:t>[발표 목적] 실제 사용 흐름이 '발견 → 해석 → 검증'으로 이어짐을 보여준다.
-[대본] 사용자는 위와 같은 흐름으로 확인합니다. 모니터링할 기업을 고르고, 최신 공시와 뉴스를 보고, 경쟁사 신호 히트맵에서 지금 주의해야 할 부분을 찾습니다. 왼쪽 화면이 그 히트맵인데, 기업별로 수주, 투자, 기술, 리스크 네 개 축에서 어떤 신호가 있는지 색으로 구분합니다. 붉은 칸이 확인이 필요한 신호입니다. 여기서 특정 신호를 클릭하면 오른쪽 화면처럼 AI가 정리한 핵심 요약과 사업 영향 분석이 나옵니다. 그리고 하단의 원문 링크로 바로 이동해 실제 공시에서 근거를 확인할 수 있습니다. 중요한 건 이 세 단계가 한 흐름 안에서 끊기지 않는다는 점입니다.
+              <a:t>[발표 목적] 실제 사용 흐름이 '발견 → 해석 → 검증'으로 끊기지 않고 이어짐을 화면으로 보여준다.
+[대본] 실제 동작 화면을 30초 영상으로 준비했습니다. 지금 보시는 것처럼 대시보드에 들어오면 상단에 AI 데일리 브리핑이 오늘 확인할 사안을 먼저 올려줍니다. 아래는 9개사 공시와 뉴스가 한 피드로 모여 있고, 여기서 주요 공시의 AI 분석을 누르면 원문을 파싱해 만든 핵심 요약 세 문장과 계약금액·지분율 같은 핵심 수치, 그리고 사업적 영향 분석이 함께 나옵니다. 경쟁사 신호 히트맵에서는 네 개 축으로 분류한 위험 신호를 한눈에 보고, 재무와 주가, 원자재 가격으로 곧바로 교차 검증할 수 있습니다. 중요한 건 이 발견과 해석과 검증이 한 흐름 안에서 끊기지 않는다는 점입니다.
 [강조할 한 문장] 발견과 해석과 검증이 한 화면 흐름 안에서 끊기지 않는다.
-[예상 시간] 70초
-[출처] 화면 캡처는 본 프로젝트에서 직접 개발한 FUTURE:M RADAR 실행 화면이다.
+[예상 시간] 70초 (영상 30초 + 설명)
+[운영 메모] 영상은 슬라이드에 삽입되어 있으며 클릭하면 재생된다. 발표 전 재생 여부를 반드시 사전 점검할 것.
+[출처] 영상은 본 프로젝트에서 직접 개발한 FUTURE:M RADAR 실행 화면을 녹화한 것이다.
 [다음 연결] 마지막으로 기대 효과와 이 과정에서 배운 점을 말씀드리겠습니다.</a:t>
             </a:r>
             <a:endParaRPr lang="en-US" dirty="0"/>
@@ -11293,12 +11294,148 @@
         </p:nvSpPr>
         <p:spPr>
           <a:xfrm>
-            <a:off x="731520" y="1938528"/>
-            <a:ext cx="1956816" cy="548640"/>
+            <a:off x="704088" y="2075688"/>
+            <a:ext cx="6821424" cy="3861511"/>
+          </a:xfrm>
+          <a:prstGeom prst="rect">
+            <a:avLst/>
+          </a:prstGeom>
+          <a:solidFill>
+            <a:srgbClr val="0B2545"/>
+          </a:solidFill>
+          <a:ln w="12700">
+            <a:solidFill>
+              <a:srgbClr val="0B2545"/>
+            </a:solidFill>
+            <a:prstDash val="solid"/>
+          </a:ln>
+        </p:spPr>
+      </p:sp>
+      <p:pic>
+        <p:nvPicPr>
+          <p:cNvPr id="3" name="Media 0">
+            <a:hlinkClick r:id="" action="ppaction://media"/>
+          </p:cNvPr>
+          <p:cNvPicPr>
+            <a:picLocks noChangeAspect="1"/>
+          </p:cNvPicPr>
+          <p:nvPr>
+            <a:videoFile r:link="rId1"/>
+            <p:extLst>
+              <p:ext uri="{DAA4B4D4-6D71-4841-9C94-3DE7FCFB9230}">
+                <p14:media xmlns:p14="http://schemas.microsoft.com/office/powerpoint/2010/main" r:embed="rId2"/>
+              </p:ext>
+            </p:extLst>
+          </p:nvPr>
+        </p:nvPicPr>
+        <p:blipFill>
+          <a:blip r:embed="rId3"/>
+          <a:stretch>
+            <a:fillRect/>
+          </a:stretch>
+        </p:blipFill>
+        <p:spPr>
+          <a:xfrm>
+            <a:off x="731520" y="2103120"/>
+            <a:ext cx="6766560" cy="3806647"/>
+          </a:xfrm>
+          <a:prstGeom prst="rect">
+            <a:avLst/>
+          </a:prstGeom>
+        </p:spPr>
+      </p:pic>
+      <p:sp>
+        <p:nvSpPr>
+          <p:cNvPr id="8" name="Text 5"/>
+          <p:cNvSpPr txBox="1"/>
+          <p:nvPr/>
+        </p:nvSpPr>
+        <p:spPr>
+          <a:xfrm>
+            <a:off x="731520" y="5980176"/>
+            <a:ext cx="6766560" cy="256032"/>
+          </a:xfrm>
+          <a:prstGeom prst="rect">
+            <a:avLst/>
+          </a:prstGeom>
+          <a:noFill/>
+          <a:ln/>
+        </p:spPr>
+        <p:txBody>
+          <a:bodyPr wrap="square" lIns="0" tIns="0" rIns="0" bIns="0" rtlCol="0" anchor="t"/>
+          <a:lstStyle/>
+          <a:p>
+            <a:pPr indent="0" marL="0">
+              <a:buNone/>
+            </a:pPr>
+            <a:r>
+              <a:rPr lang="en-US" sz="1350" dirty="0">
+                <a:solidFill>
+                  <a:srgbClr val="8B9BAA"/>
+                </a:solidFill>
+                <a:latin typeface="함초롬돋움" pitchFamily="34" charset="0"/>
+                <a:ea typeface="함초롬돋움" pitchFamily="34" charset="-122"/>
+                <a:cs typeface="함초롬돋움" pitchFamily="34" charset="-120"/>
+              </a:rPr>
+              <a:t>실제 화면 시연 · 30초 (재생 버튼을 눌러 시작)</a:t>
+            </a:r>
+            <a:endParaRPr lang="en-US" sz="1350" dirty="0"/>
+          </a:p>
+        </p:txBody>
+      </p:sp>
+      <p:sp>
+        <p:nvSpPr>
+          <p:cNvPr id="9" name="Text 6"/>
+          <p:cNvSpPr txBox="1"/>
+          <p:nvPr/>
+        </p:nvSpPr>
+        <p:spPr>
+          <a:xfrm>
+            <a:off x="7799832" y="2084832"/>
+            <a:ext cx="3657600" cy="292608"/>
+          </a:xfrm>
+          <a:prstGeom prst="rect">
+            <a:avLst/>
+          </a:prstGeom>
+          <a:noFill/>
+          <a:ln/>
+        </p:spPr>
+        <p:txBody>
+          <a:bodyPr wrap="square" lIns="0" tIns="0" rIns="0" bIns="0" rtlCol="0" anchor="t"/>
+          <a:lstStyle/>
+          <a:p>
+            <a:pPr indent="0" marL="0">
+              <a:buNone/>
+            </a:pPr>
+            <a:r>
+              <a:rPr lang="en-US" sz="1800" b="1" dirty="0">
+                <a:solidFill>
+                  <a:srgbClr val="0B2545"/>
+                </a:solidFill>
+                <a:latin typeface="함초롬돋움" pitchFamily="34" charset="0"/>
+                <a:ea typeface="함초롬돋움" pitchFamily="34" charset="-122"/>
+                <a:cs typeface="함초롬돋움" pitchFamily="34" charset="-120"/>
+              </a:rPr>
+              <a:t>사용 흐름</a:t>
+            </a:r>
+            <a:endParaRPr lang="en-US" sz="1800" dirty="0"/>
+          </a:p>
+        </p:txBody>
+      </p:sp>
+      <p:sp>
+        <p:nvSpPr>
+          <p:cNvPr id="10" name="Shape 7"/>
+          <p:cNvSpPr/>
+          <p:nvPr/>
+        </p:nvSpPr>
+        <p:spPr>
+          <a:xfrm>
+            <a:off x="7799832" y="2487168"/>
+            <a:ext cx="3657600" cy="402336"/>
           </a:xfrm>
           <a:prstGeom prst="roundRect">
             <a:avLst>
-              <a:gd name="adj" fmla="val 8333"/>
+              <a:gd name="adj" fmla="val 11364"/>
             </a:avLst>
           </a:prstGeom>
           <a:solidFill>
@@ -11314,35 +11451,71 @@
       </p:sp>
       <p:sp>
         <p:nvSpPr>
-          <p:cNvPr id="7" name="Text 5"/>
-          <p:cNvSpPr txBox="1"/>
-          <p:nvPr/>
-        </p:nvSpPr>
-        <p:spPr>
-          <a:xfrm>
-            <a:off x="804672" y="2048256"/>
-            <a:ext cx="1810512" cy="365760"/>
-          </a:xfrm>
-          <a:prstGeom prst="rect">
-            <a:avLst/>
-          </a:prstGeom>
-          <a:noFill/>
-          <a:ln/>
-        </p:spPr>
-        <p:txBody>
-          <a:bodyPr wrap="square" lIns="0" tIns="0" rIns="0" bIns="0" rtlCol="0" anchor="t"/>
-          <a:lstStyle/>
-          <a:p>
-            <a:pPr algn="ctr" indent="0" marL="0">
-              <a:lnSpc>
-                <a:spcPts val="1600"/>
-              </a:lnSpc>
+          <p:cNvPr id="11" name="Text 8"/>
+          <p:cNvSpPr txBox="1"/>
+          <p:nvPr/>
+        </p:nvSpPr>
+        <p:spPr>
+          <a:xfrm>
+            <a:off x="7964424" y="2569464"/>
+            <a:ext cx="274320" cy="237744"/>
+          </a:xfrm>
+          <a:prstGeom prst="rect">
+            <a:avLst/>
+          </a:prstGeom>
+          <a:noFill/>
+          <a:ln/>
+        </p:spPr>
+        <p:txBody>
+          <a:bodyPr wrap="square" lIns="0" tIns="0" rIns="0" bIns="0" rtlCol="0" anchor="t"/>
+          <a:lstStyle/>
+          <a:p>
+            <a:pPr indent="0" marL="0">
               <a:buNone/>
             </a:pPr>
             <a:r>
               <a:rPr lang="en-US" sz="1300" b="1" dirty="0">
                 <a:solidFill>
-                  <a:srgbClr val="143A63"/>
+                  <a:srgbClr val="1E6FBF"/>
+                </a:solidFill>
+                <a:latin typeface="함초롬돋움" pitchFamily="34" charset="0"/>
+                <a:ea typeface="함초롬돋움" pitchFamily="34" charset="-122"/>
+                <a:cs typeface="함초롬돋움" pitchFamily="34" charset="-120"/>
+              </a:rPr>
+              <a:t>1</a:t>
+            </a:r>
+            <a:endParaRPr lang="en-US" sz="1300" dirty="0"/>
+          </a:p>
+        </p:txBody>
+      </p:sp>
+      <p:sp>
+        <p:nvSpPr>
+          <p:cNvPr id="12" name="Text 9"/>
+          <p:cNvSpPr txBox="1"/>
+          <p:nvPr/>
+        </p:nvSpPr>
+        <p:spPr>
+          <a:xfrm>
+            <a:off x="8275320" y="2560320"/>
+            <a:ext cx="3017520" cy="256032"/>
+          </a:xfrm>
+          <a:prstGeom prst="rect">
+            <a:avLst/>
+          </a:prstGeom>
+          <a:noFill/>
+          <a:ln/>
+        </p:spPr>
+        <p:txBody>
+          <a:bodyPr wrap="square" lIns="0" tIns="0" rIns="0" bIns="0" rtlCol="0" anchor="t"/>
+          <a:lstStyle/>
+          <a:p>
+            <a:pPr indent="0" marL="0">
+              <a:buNone/>
+            </a:pPr>
+            <a:r>
+              <a:rPr lang="en-US" sz="1450" b="1" dirty="0">
+                <a:solidFill>
+                  <a:srgbClr val="16273A"/>
                 </a:solidFill>
                 <a:latin typeface="함초롬돋움" pitchFamily="34" charset="0"/>
                 <a:ea typeface="함초롬돋움" pitchFamily="34" charset="-122"/>
@@ -11350,20 +11523,20 @@
               </a:rPr>
               <a:t>모니터링 기업 선택</a:t>
             </a:r>
-            <a:endParaRPr lang="en-US" sz="1300" dirty="0"/>
-          </a:p>
-        </p:txBody>
-      </p:sp>
-      <p:sp>
-        <p:nvSpPr>
-          <p:cNvPr id="8" name="Shape 6"/>
-          <p:cNvSpPr/>
-          <p:nvPr/>
-        </p:nvSpPr>
-        <p:spPr>
-          <a:xfrm>
-            <a:off x="2688336" y="2212848"/>
-            <a:ext cx="237744" cy="0"/>
+            <a:endParaRPr lang="en-US" sz="1450" dirty="0"/>
+          </a:p>
+        </p:txBody>
+      </p:sp>
+      <p:sp>
+        <p:nvSpPr>
+          <p:cNvPr id="13" name="Shape 10"/>
+          <p:cNvSpPr/>
+          <p:nvPr/>
+        </p:nvSpPr>
+        <p:spPr>
+          <a:xfrm>
+            <a:off x="9628632" y="2889504"/>
+            <a:ext cx="0" cy="73152"/>
           </a:xfrm>
           <a:prstGeom prst="line">
             <a:avLst/>
@@ -11379,18 +11552,18 @@
       </p:sp>
       <p:sp>
         <p:nvSpPr>
-          <p:cNvPr id="9" name="Shape 7"/>
-          <p:cNvSpPr/>
-          <p:nvPr/>
-        </p:nvSpPr>
-        <p:spPr>
-          <a:xfrm>
-            <a:off x="2926080" y="1938528"/>
-            <a:ext cx="1956816" cy="548640"/>
+          <p:cNvPr id="14" name="Shape 11"/>
+          <p:cNvSpPr/>
+          <p:nvPr/>
+        </p:nvSpPr>
+        <p:spPr>
+          <a:xfrm>
+            <a:off x="7799832" y="2962656"/>
+            <a:ext cx="3657600" cy="402336"/>
           </a:xfrm>
           <a:prstGeom prst="roundRect">
             <a:avLst>
-              <a:gd name="adj" fmla="val 8333"/>
+              <a:gd name="adj" fmla="val 11364"/>
             </a:avLst>
           </a:prstGeom>
           <a:solidFill>
@@ -11406,35 +11579,71 @@
       </p:sp>
       <p:sp>
         <p:nvSpPr>
-          <p:cNvPr id="10" name="Text 8"/>
-          <p:cNvSpPr txBox="1"/>
-          <p:nvPr/>
-        </p:nvSpPr>
-        <p:spPr>
-          <a:xfrm>
-            <a:off x="2999232" y="2048256"/>
-            <a:ext cx="1810512" cy="365760"/>
-          </a:xfrm>
-          <a:prstGeom prst="rect">
-            <a:avLst/>
-          </a:prstGeom>
-          <a:noFill/>
-          <a:ln/>
-        </p:spPr>
-        <p:txBody>
-          <a:bodyPr wrap="square" lIns="0" tIns="0" rIns="0" bIns="0" rtlCol="0" anchor="t"/>
-          <a:lstStyle/>
-          <a:p>
-            <a:pPr algn="ctr" indent="0" marL="0">
-              <a:lnSpc>
-                <a:spcPts val="1600"/>
-              </a:lnSpc>
+          <p:cNvPr id="15" name="Text 12"/>
+          <p:cNvSpPr txBox="1"/>
+          <p:nvPr/>
+        </p:nvSpPr>
+        <p:spPr>
+          <a:xfrm>
+            <a:off x="7964424" y="3044952"/>
+            <a:ext cx="274320" cy="237744"/>
+          </a:xfrm>
+          <a:prstGeom prst="rect">
+            <a:avLst/>
+          </a:prstGeom>
+          <a:noFill/>
+          <a:ln/>
+        </p:spPr>
+        <p:txBody>
+          <a:bodyPr wrap="square" lIns="0" tIns="0" rIns="0" bIns="0" rtlCol="0" anchor="t"/>
+          <a:lstStyle/>
+          <a:p>
+            <a:pPr indent="0" marL="0">
               <a:buNone/>
             </a:pPr>
             <a:r>
               <a:rPr lang="en-US" sz="1300" b="1" dirty="0">
                 <a:solidFill>
-                  <a:srgbClr val="143A63"/>
+                  <a:srgbClr val="1E6FBF"/>
+                </a:solidFill>
+                <a:latin typeface="함초롬돋움" pitchFamily="34" charset="0"/>
+                <a:ea typeface="함초롬돋움" pitchFamily="34" charset="-122"/>
+                <a:cs typeface="함초롬돋움" pitchFamily="34" charset="-120"/>
+              </a:rPr>
+              <a:t>2</a:t>
+            </a:r>
+            <a:endParaRPr lang="en-US" sz="1300" dirty="0"/>
+          </a:p>
+        </p:txBody>
+      </p:sp>
+      <p:sp>
+        <p:nvSpPr>
+          <p:cNvPr id="16" name="Text 13"/>
+          <p:cNvSpPr txBox="1"/>
+          <p:nvPr/>
+        </p:nvSpPr>
+        <p:spPr>
+          <a:xfrm>
+            <a:off x="8275320" y="3035808"/>
+            <a:ext cx="3017520" cy="256032"/>
+          </a:xfrm>
+          <a:prstGeom prst="rect">
+            <a:avLst/>
+          </a:prstGeom>
+          <a:noFill/>
+          <a:ln/>
+        </p:spPr>
+        <p:txBody>
+          <a:bodyPr wrap="square" lIns="0" tIns="0" rIns="0" bIns="0" rtlCol="0" anchor="t"/>
+          <a:lstStyle/>
+          <a:p>
+            <a:pPr indent="0" marL="0">
+              <a:buNone/>
+            </a:pPr>
+            <a:r>
+              <a:rPr lang="en-US" sz="1450" b="1" dirty="0">
+                <a:solidFill>
+                  <a:srgbClr val="16273A"/>
                 </a:solidFill>
                 <a:latin typeface="함초롬돋움" pitchFamily="34" charset="0"/>
                 <a:ea typeface="함초롬돋움" pitchFamily="34" charset="-122"/>
@@ -11442,20 +11651,20 @@
               </a:rPr>
               <a:t>공시 · 뉴스 확인</a:t>
             </a:r>
-            <a:endParaRPr lang="en-US" sz="1300" dirty="0"/>
-          </a:p>
-        </p:txBody>
-      </p:sp>
-      <p:sp>
-        <p:nvSpPr>
-          <p:cNvPr id="11" name="Shape 9"/>
-          <p:cNvSpPr/>
-          <p:nvPr/>
-        </p:nvSpPr>
-        <p:spPr>
-          <a:xfrm>
-            <a:off x="4882896" y="2212848"/>
-            <a:ext cx="237744" cy="0"/>
+            <a:endParaRPr lang="en-US" sz="1450" dirty="0"/>
+          </a:p>
+        </p:txBody>
+      </p:sp>
+      <p:sp>
+        <p:nvSpPr>
+          <p:cNvPr id="17" name="Shape 14"/>
+          <p:cNvSpPr/>
+          <p:nvPr/>
+        </p:nvSpPr>
+        <p:spPr>
+          <a:xfrm>
+            <a:off x="9628632" y="3364992"/>
+            <a:ext cx="0" cy="73152"/>
           </a:xfrm>
           <a:prstGeom prst="line">
             <a:avLst/>
@@ -11471,18 +11680,18 @@
       </p:sp>
       <p:sp>
         <p:nvSpPr>
-          <p:cNvPr id="12" name="Shape 10"/>
-          <p:cNvSpPr/>
-          <p:nvPr/>
-        </p:nvSpPr>
-        <p:spPr>
-          <a:xfrm>
-            <a:off x="5120640" y="1938528"/>
-            <a:ext cx="1956816" cy="548640"/>
+          <p:cNvPr id="18" name="Shape 15"/>
+          <p:cNvSpPr/>
+          <p:nvPr/>
+        </p:nvSpPr>
+        <p:spPr>
+          <a:xfrm>
+            <a:off x="7799832" y="3438144"/>
+            <a:ext cx="3657600" cy="402336"/>
           </a:xfrm>
           <a:prstGeom prst="roundRect">
             <a:avLst>
-              <a:gd name="adj" fmla="val 8333"/>
+              <a:gd name="adj" fmla="val 11364"/>
             </a:avLst>
           </a:prstGeom>
           <a:solidFill>
@@ -11498,35 +11707,71 @@
       </p:sp>
       <p:sp>
         <p:nvSpPr>
-          <p:cNvPr id="13" name="Text 11"/>
-          <p:cNvSpPr txBox="1"/>
-          <p:nvPr/>
-        </p:nvSpPr>
-        <p:spPr>
-          <a:xfrm>
-            <a:off x="5193792" y="2048256"/>
-            <a:ext cx="1810512" cy="365760"/>
-          </a:xfrm>
-          <a:prstGeom prst="rect">
-            <a:avLst/>
-          </a:prstGeom>
-          <a:noFill/>
-          <a:ln/>
-        </p:spPr>
-        <p:txBody>
-          <a:bodyPr wrap="square" lIns="0" tIns="0" rIns="0" bIns="0" rtlCol="0" anchor="t"/>
-          <a:lstStyle/>
-          <a:p>
-            <a:pPr algn="ctr" indent="0" marL="0">
-              <a:lnSpc>
-                <a:spcPts val="1600"/>
-              </a:lnSpc>
+          <p:cNvPr id="19" name="Text 16"/>
+          <p:cNvSpPr txBox="1"/>
+          <p:nvPr/>
+        </p:nvSpPr>
+        <p:spPr>
+          <a:xfrm>
+            <a:off x="7964424" y="3520440"/>
+            <a:ext cx="274320" cy="237744"/>
+          </a:xfrm>
+          <a:prstGeom prst="rect">
+            <a:avLst/>
+          </a:prstGeom>
+          <a:noFill/>
+          <a:ln/>
+        </p:spPr>
+        <p:txBody>
+          <a:bodyPr wrap="square" lIns="0" tIns="0" rIns="0" bIns="0" rtlCol="0" anchor="t"/>
+          <a:lstStyle/>
+          <a:p>
+            <a:pPr indent="0" marL="0">
               <a:buNone/>
             </a:pPr>
             <a:r>
               <a:rPr lang="en-US" sz="1300" b="1" dirty="0">
                 <a:solidFill>
-                  <a:srgbClr val="143A63"/>
+                  <a:srgbClr val="1E6FBF"/>
+                </a:solidFill>
+                <a:latin typeface="함초롬돋움" pitchFamily="34" charset="0"/>
+                <a:ea typeface="함초롬돋움" pitchFamily="34" charset="-122"/>
+                <a:cs typeface="함초롬돋움" pitchFamily="34" charset="-120"/>
+              </a:rPr>
+              <a:t>3</a:t>
+            </a:r>
+            <a:endParaRPr lang="en-US" sz="1300" dirty="0"/>
+          </a:p>
+        </p:txBody>
+      </p:sp>
+      <p:sp>
+        <p:nvSpPr>
+          <p:cNvPr id="20" name="Text 17"/>
+          <p:cNvSpPr txBox="1"/>
+          <p:nvPr/>
+        </p:nvSpPr>
+        <p:spPr>
+          <a:xfrm>
+            <a:off x="8275320" y="3511296"/>
+            <a:ext cx="3017520" cy="256032"/>
+          </a:xfrm>
+          <a:prstGeom prst="rect">
+            <a:avLst/>
+          </a:prstGeom>
+          <a:noFill/>
+          <a:ln/>
+        </p:spPr>
+        <p:txBody>
+          <a:bodyPr wrap="square" lIns="0" tIns="0" rIns="0" bIns="0" rtlCol="0" anchor="t"/>
+          <a:lstStyle/>
+          <a:p>
+            <a:pPr indent="0" marL="0">
+              <a:buNone/>
+            </a:pPr>
+            <a:r>
+              <a:rPr lang="en-US" sz="1450" b="1" dirty="0">
+                <a:solidFill>
+                  <a:srgbClr val="16273A"/>
                 </a:solidFill>
                 <a:latin typeface="함초롬돋움" pitchFamily="34" charset="0"/>
                 <a:ea typeface="함초롬돋움" pitchFamily="34" charset="-122"/>
@@ -11534,20 +11779,20 @@
               </a:rPr>
               <a:t>히트맵에서 위험 확인</a:t>
             </a:r>
-            <a:endParaRPr lang="en-US" sz="1300" dirty="0"/>
-          </a:p>
-        </p:txBody>
-      </p:sp>
-      <p:sp>
-        <p:nvSpPr>
-          <p:cNvPr id="14" name="Shape 12"/>
-          <p:cNvSpPr/>
-          <p:nvPr/>
-        </p:nvSpPr>
-        <p:spPr>
-          <a:xfrm>
-            <a:off x="7077456" y="2212848"/>
-            <a:ext cx="237744" cy="0"/>
+            <a:endParaRPr lang="en-US" sz="1450" dirty="0"/>
+          </a:p>
+        </p:txBody>
+      </p:sp>
+      <p:sp>
+        <p:nvSpPr>
+          <p:cNvPr id="21" name="Shape 18"/>
+          <p:cNvSpPr/>
+          <p:nvPr/>
+        </p:nvSpPr>
+        <p:spPr>
+          <a:xfrm>
+            <a:off x="9628632" y="3840480"/>
+            <a:ext cx="0" cy="73152"/>
           </a:xfrm>
           <a:prstGeom prst="line">
             <a:avLst/>
@@ -11563,18 +11808,18 @@
       </p:sp>
       <p:sp>
         <p:nvSpPr>
-          <p:cNvPr id="15" name="Shape 13"/>
-          <p:cNvSpPr/>
-          <p:nvPr/>
-        </p:nvSpPr>
-        <p:spPr>
-          <a:xfrm>
-            <a:off x="7315200" y="1938528"/>
-            <a:ext cx="1956816" cy="548640"/>
+          <p:cNvPr id="22" name="Shape 19"/>
+          <p:cNvSpPr/>
+          <p:nvPr/>
+        </p:nvSpPr>
+        <p:spPr>
+          <a:xfrm>
+            <a:off x="7799832" y="3913632"/>
+            <a:ext cx="3657600" cy="402336"/>
           </a:xfrm>
           <a:prstGeom prst="roundRect">
             <a:avLst>
-              <a:gd name="adj" fmla="val 8333"/>
+              <a:gd name="adj" fmla="val 11364"/>
             </a:avLst>
           </a:prstGeom>
           <a:solidFill>
@@ -11590,35 +11835,71 @@
       </p:sp>
       <p:sp>
         <p:nvSpPr>
-          <p:cNvPr id="16" name="Text 14"/>
-          <p:cNvSpPr txBox="1"/>
-          <p:nvPr/>
-        </p:nvSpPr>
-        <p:spPr>
-          <a:xfrm>
-            <a:off x="7388352" y="2048256"/>
-            <a:ext cx="1810512" cy="365760"/>
-          </a:xfrm>
-          <a:prstGeom prst="rect">
-            <a:avLst/>
-          </a:prstGeom>
-          <a:noFill/>
-          <a:ln/>
-        </p:spPr>
-        <p:txBody>
-          <a:bodyPr wrap="square" lIns="0" tIns="0" rIns="0" bIns="0" rtlCol="0" anchor="t"/>
-          <a:lstStyle/>
-          <a:p>
-            <a:pPr algn="ctr" indent="0" marL="0">
-              <a:lnSpc>
-                <a:spcPts val="1600"/>
-              </a:lnSpc>
+          <p:cNvPr id="23" name="Text 20"/>
+          <p:cNvSpPr txBox="1"/>
+          <p:nvPr/>
+        </p:nvSpPr>
+        <p:spPr>
+          <a:xfrm>
+            <a:off x="7964424" y="3995928"/>
+            <a:ext cx="274320" cy="237744"/>
+          </a:xfrm>
+          <a:prstGeom prst="rect">
+            <a:avLst/>
+          </a:prstGeom>
+          <a:noFill/>
+          <a:ln/>
+        </p:spPr>
+        <p:txBody>
+          <a:bodyPr wrap="square" lIns="0" tIns="0" rIns="0" bIns="0" rtlCol="0" anchor="t"/>
+          <a:lstStyle/>
+          <a:p>
+            <a:pPr indent="0" marL="0">
               <a:buNone/>
             </a:pPr>
             <a:r>
               <a:rPr lang="en-US" sz="1300" b="1" dirty="0">
                 <a:solidFill>
-                  <a:srgbClr val="143A63"/>
+                  <a:srgbClr val="1E6FBF"/>
+                </a:solidFill>
+                <a:latin typeface="함초롬돋움" pitchFamily="34" charset="0"/>
+                <a:ea typeface="함초롬돋움" pitchFamily="34" charset="-122"/>
+                <a:cs typeface="함초롬돋움" pitchFamily="34" charset="-120"/>
+              </a:rPr>
+              <a:t>4</a:t>
+            </a:r>
+            <a:endParaRPr lang="en-US" sz="1300" dirty="0"/>
+          </a:p>
+        </p:txBody>
+      </p:sp>
+      <p:sp>
+        <p:nvSpPr>
+          <p:cNvPr id="24" name="Text 21"/>
+          <p:cNvSpPr txBox="1"/>
+          <p:nvPr/>
+        </p:nvSpPr>
+        <p:spPr>
+          <a:xfrm>
+            <a:off x="8275320" y="3986784"/>
+            <a:ext cx="3017520" cy="256032"/>
+          </a:xfrm>
+          <a:prstGeom prst="rect">
+            <a:avLst/>
+          </a:prstGeom>
+          <a:noFill/>
+          <a:ln/>
+        </p:spPr>
+        <p:txBody>
+          <a:bodyPr wrap="square" lIns="0" tIns="0" rIns="0" bIns="0" rtlCol="0" anchor="t"/>
+          <a:lstStyle/>
+          <a:p>
+            <a:pPr indent="0" marL="0">
+              <a:buNone/>
+            </a:pPr>
+            <a:r>
+              <a:rPr lang="en-US" sz="1450" b="1" dirty="0">
+                <a:solidFill>
+                  <a:srgbClr val="16273A"/>
                 </a:solidFill>
                 <a:latin typeface="함초롬돋움" pitchFamily="34" charset="0"/>
                 <a:ea typeface="함초롬돋움" pitchFamily="34" charset="-122"/>
@@ -11626,20 +11907,20 @@
               </a:rPr>
               <a:t>AI 임플리케이션 확인</a:t>
             </a:r>
-            <a:endParaRPr lang="en-US" sz="1300" dirty="0"/>
-          </a:p>
-        </p:txBody>
-      </p:sp>
-      <p:sp>
-        <p:nvSpPr>
-          <p:cNvPr id="17" name="Shape 15"/>
-          <p:cNvSpPr/>
-          <p:nvPr/>
-        </p:nvSpPr>
-        <p:spPr>
-          <a:xfrm>
-            <a:off x="9272016" y="2212848"/>
-            <a:ext cx="237744" cy="0"/>
+            <a:endParaRPr lang="en-US" sz="1450" dirty="0"/>
+          </a:p>
+        </p:txBody>
+      </p:sp>
+      <p:sp>
+        <p:nvSpPr>
+          <p:cNvPr id="25" name="Shape 22"/>
+          <p:cNvSpPr/>
+          <p:nvPr/>
+        </p:nvSpPr>
+        <p:spPr>
+          <a:xfrm>
+            <a:off x="9628632" y="4315968"/>
+            <a:ext cx="0" cy="73152"/>
           </a:xfrm>
           <a:prstGeom prst="line">
             <a:avLst/>
@@ -11655,18 +11936,18 @@
       </p:sp>
       <p:sp>
         <p:nvSpPr>
-          <p:cNvPr id="18" name="Shape 16"/>
-          <p:cNvSpPr/>
-          <p:nvPr/>
-        </p:nvSpPr>
-        <p:spPr>
-          <a:xfrm>
-            <a:off x="9509760" y="1938528"/>
-            <a:ext cx="1956816" cy="548640"/>
+          <p:cNvPr id="26" name="Shape 23"/>
+          <p:cNvSpPr/>
+          <p:nvPr/>
+        </p:nvSpPr>
+        <p:spPr>
+          <a:xfrm>
+            <a:off x="7799832" y="4389120"/>
+            <a:ext cx="3657600" cy="402336"/>
           </a:xfrm>
           <a:prstGeom prst="roundRect">
             <a:avLst>
-              <a:gd name="adj" fmla="val 8333"/>
+              <a:gd name="adj" fmla="val 11364"/>
             </a:avLst>
           </a:prstGeom>
           <a:solidFill>
@@ -11682,29 +11963,26 @@
       </p:sp>
       <p:sp>
         <p:nvSpPr>
-          <p:cNvPr id="19" name="Text 17"/>
-          <p:cNvSpPr txBox="1"/>
-          <p:nvPr/>
-        </p:nvSpPr>
-        <p:spPr>
-          <a:xfrm>
-            <a:off x="9582912" y="2048256"/>
-            <a:ext cx="1810512" cy="365760"/>
-          </a:xfrm>
-          <a:prstGeom prst="rect">
-            <a:avLst/>
-          </a:prstGeom>
-          <a:noFill/>
-          <a:ln/>
-        </p:spPr>
-        <p:txBody>
-          <a:bodyPr wrap="square" lIns="0" tIns="0" rIns="0" bIns="0" rtlCol="0" anchor="t"/>
-          <a:lstStyle/>
-          <a:p>
-            <a:pPr algn="ctr" indent="0" marL="0">
-              <a:lnSpc>
-                <a:spcPts val="1600"/>
-              </a:lnSpc>
+          <p:cNvPr id="27" name="Text 24"/>
+          <p:cNvSpPr txBox="1"/>
+          <p:nvPr/>
+        </p:nvSpPr>
+        <p:spPr>
+          <a:xfrm>
+            <a:off x="7964424" y="4471416"/>
+            <a:ext cx="274320" cy="237744"/>
+          </a:xfrm>
+          <a:prstGeom prst="rect">
+            <a:avLst/>
+          </a:prstGeom>
+          <a:noFill/>
+          <a:ln/>
+        </p:spPr>
+        <p:txBody>
+          <a:bodyPr wrap="square" lIns="0" tIns="0" rIns="0" bIns="0" rtlCol="0" anchor="t"/>
+          <a:lstStyle/>
+          <a:p>
+            <a:pPr indent="0" marL="0">
               <a:buNone/>
             </a:pPr>
             <a:r>
@@ -11716,30 +11994,67 @@
                 <a:ea typeface="함초롬돋움" pitchFamily="34" charset="-122"/>
                 <a:cs typeface="함초롬돋움" pitchFamily="34" charset="-120"/>
               </a:rPr>
+              <a:t>5</a:t>
+            </a:r>
+            <a:endParaRPr lang="en-US" sz="1300" dirty="0"/>
+          </a:p>
+        </p:txBody>
+      </p:sp>
+      <p:sp>
+        <p:nvSpPr>
+          <p:cNvPr id="28" name="Text 25"/>
+          <p:cNvSpPr txBox="1"/>
+          <p:nvPr/>
+        </p:nvSpPr>
+        <p:spPr>
+          <a:xfrm>
+            <a:off x="8275320" y="4462272"/>
+            <a:ext cx="3017520" cy="256032"/>
+          </a:xfrm>
+          <a:prstGeom prst="rect">
+            <a:avLst/>
+          </a:prstGeom>
+          <a:noFill/>
+          <a:ln/>
+        </p:spPr>
+        <p:txBody>
+          <a:bodyPr wrap="square" lIns="0" tIns="0" rIns="0" bIns="0" rtlCol="0" anchor="t"/>
+          <a:lstStyle/>
+          <a:p>
+            <a:pPr indent="0" marL="0">
+              <a:buNone/>
+            </a:pPr>
+            <a:r>
+              <a:rPr lang="en-US" sz="1450" b="1" dirty="0">
+                <a:solidFill>
+                  <a:srgbClr val="007A68"/>
+                </a:solidFill>
+                <a:latin typeface="함초롬돋움" pitchFamily="34" charset="0"/>
+                <a:ea typeface="함초롬돋움" pitchFamily="34" charset="-122"/>
+                <a:cs typeface="함초롬돋움" pitchFamily="34" charset="-120"/>
+              </a:rPr>
               <a:t>원문에서 근거 검증</a:t>
             </a:r>
-            <a:endParaRPr lang="en-US" sz="1300" dirty="0"/>
-          </a:p>
-        </p:txBody>
-      </p:sp>
-      <p:sp>
-        <p:nvSpPr>
-          <p:cNvPr id="20" name="Shape 18"/>
-          <p:cNvSpPr/>
-          <p:nvPr/>
-        </p:nvSpPr>
-        <p:spPr>
-          <a:xfrm>
-            <a:off x="731520" y="2706624"/>
-            <a:ext cx="5230368" cy="2761488"/>
-          </a:xfrm>
-          <a:prstGeom prst="roundRect">
-            <a:avLst>
-              <a:gd name="adj" fmla="val 1656"/>
-            </a:avLst>
+            <a:endParaRPr lang="en-US" sz="1450" dirty="0"/>
+          </a:p>
+        </p:txBody>
+      </p:sp>
+      <p:sp>
+        <p:nvSpPr>
+          <p:cNvPr id="29" name="Shape 26"/>
+          <p:cNvSpPr/>
+          <p:nvPr/>
+        </p:nvSpPr>
+        <p:spPr>
+          <a:xfrm>
+            <a:off x="7799832" y="4956048"/>
+            <a:ext cx="3657600" cy="16459"/>
+          </a:xfrm>
+          <a:prstGeom prst="rect">
+            <a:avLst/>
           </a:prstGeom>
           <a:solidFill>
-            <a:srgbClr val="FFFFFF"/>
+            <a:srgbClr val="D2DEEA"/>
           </a:solidFill>
           <a:ln w="12700">
             <a:solidFill>
@@ -11751,167 +12066,14 @@
       </p:sp>
       <p:sp>
         <p:nvSpPr>
-          <p:cNvPr id="21" name="Text 19"/>
-          <p:cNvSpPr txBox="1"/>
-          <p:nvPr/>
-        </p:nvSpPr>
-        <p:spPr>
-          <a:xfrm>
-            <a:off x="950976" y="2852928"/>
-            <a:ext cx="4754880" cy="274320"/>
-          </a:xfrm>
-          <a:prstGeom prst="rect">
-            <a:avLst/>
-          </a:prstGeom>
-          <a:noFill/>
-          <a:ln/>
-        </p:spPr>
-        <p:txBody>
-          <a:bodyPr wrap="square" lIns="0" tIns="0" rIns="0" bIns="0" rtlCol="0" anchor="t"/>
-          <a:lstStyle/>
-          <a:p>
-            <a:pPr indent="0" marL="0">
-              <a:buNone/>
-            </a:pPr>
-            <a:r>
-              <a:rPr lang="en-US" sz="1600" b="1" dirty="0">
-                <a:solidFill>
-                  <a:srgbClr val="0B2545"/>
-                </a:solidFill>
-                <a:latin typeface="함초롬돋움" pitchFamily="34" charset="0"/>
-                <a:ea typeface="함초롬돋움" pitchFamily="34" charset="-122"/>
-                <a:cs typeface="함초롬돋움" pitchFamily="34" charset="-120"/>
-              </a:rPr>
-              <a:t>경쟁사 신호 히트맵</a:t>
-            </a:r>
-            <a:endParaRPr lang="en-US" sz="1600" dirty="0"/>
-          </a:p>
-        </p:txBody>
-      </p:sp>
-      <p:pic>
-        <p:nvPicPr>
-          <p:cNvPr id="22" name="Image 0" descr="C:\Users\POSCOFUTUREM\AppData\Local\Temp\claude\C--Users-POSCOFUTUREM-Desktop-FUTURE-M-RADAR\03eb9f10-e059-4022-9426-4bcf8a16f4d4\scratchpad\assets\heatmap.png">    </p:cNvPr>
-          <p:cNvPicPr>
-            <a:picLocks noChangeAspect="1"/>
-          </p:cNvPicPr>
-          <p:nvPr/>
-        </p:nvPicPr>
-        <p:blipFill>
-          <a:blip r:embed="rId1"/>
-          <a:stretch>
-            <a:fillRect/>
-          </a:stretch>
-        </p:blipFill>
-        <p:spPr>
-          <a:xfrm>
-            <a:off x="950976" y="3200400"/>
-            <a:ext cx="4791456" cy="2121408"/>
-          </a:xfrm>
-          <a:prstGeom prst="rect">
-            <a:avLst/>
-          </a:prstGeom>
-        </p:spPr>
-      </p:pic>
-      <p:sp>
-        <p:nvSpPr>
-          <p:cNvPr id="23" name="Shape 20"/>
-          <p:cNvSpPr/>
-          <p:nvPr/>
-        </p:nvSpPr>
-        <p:spPr>
-          <a:xfrm>
-            <a:off x="6336792" y="2706624"/>
-            <a:ext cx="5120640" cy="2761488"/>
-          </a:xfrm>
-          <a:prstGeom prst="roundRect">
-            <a:avLst>
-              <a:gd name="adj" fmla="val 1656"/>
-            </a:avLst>
-          </a:prstGeom>
-          <a:solidFill>
-            <a:srgbClr val="FFFFFF"/>
-          </a:solidFill>
-          <a:ln w="12700">
-            <a:solidFill>
-              <a:srgbClr val="D2DEEA"/>
-            </a:solidFill>
-            <a:prstDash val="solid"/>
-          </a:ln>
-        </p:spPr>
-      </p:sp>
-      <p:sp>
-        <p:nvSpPr>
-          <p:cNvPr id="24" name="Text 21"/>
-          <p:cNvSpPr txBox="1"/>
-          <p:nvPr/>
-        </p:nvSpPr>
-        <p:spPr>
-          <a:xfrm>
-            <a:off x="6556248" y="2852928"/>
-            <a:ext cx="4663440" cy="274320"/>
-          </a:xfrm>
-          <a:prstGeom prst="rect">
-            <a:avLst/>
-          </a:prstGeom>
-          <a:noFill/>
-          <a:ln/>
-        </p:spPr>
-        <p:txBody>
-          <a:bodyPr wrap="square" lIns="0" tIns="0" rIns="0" bIns="0" rtlCol="0" anchor="t"/>
-          <a:lstStyle/>
-          <a:p>
-            <a:pPr indent="0" marL="0">
-              <a:buNone/>
-            </a:pPr>
-            <a:r>
-              <a:rPr lang="en-US" sz="1600" b="1" dirty="0">
-                <a:solidFill>
-                  <a:srgbClr val="0B2545"/>
-                </a:solidFill>
-                <a:latin typeface="함초롬돋움" pitchFamily="34" charset="0"/>
-                <a:ea typeface="함초롬돋움" pitchFamily="34" charset="-122"/>
-                <a:cs typeface="함초롬돋움" pitchFamily="34" charset="-120"/>
-              </a:rPr>
-              <a:t>AI 분석과 사업 임플리케이션</a:t>
-            </a:r>
-            <a:endParaRPr lang="en-US" sz="1600" dirty="0"/>
-          </a:p>
-        </p:txBody>
-      </p:sp>
-      <p:pic>
-        <p:nvPicPr>
-          <p:cNvPr id="25" name="Image 1" descr="C:\Users\POSCOFUTUREM\AppData\Local\Temp\claude\C--Users-POSCOFUTUREM-Desktop-FUTURE-M-RADAR\03eb9f10-e059-4022-9426-4bcf8a16f4d4\scratchpad\assets\ai-modal.png">    </p:cNvPr>
-          <p:cNvPicPr>
-            <a:picLocks noChangeAspect="1"/>
-          </p:cNvPicPr>
-          <p:nvPr/>
-        </p:nvPicPr>
-        <p:blipFill>
-          <a:blip r:embed="rId2"/>
-          <a:stretch>
-            <a:fillRect/>
-          </a:stretch>
-        </p:blipFill>
-        <p:spPr>
-          <a:xfrm>
-            <a:off x="7251192" y="3200400"/>
-            <a:ext cx="3291840" cy="2103120"/>
-          </a:xfrm>
-          <a:prstGeom prst="rect">
-            <a:avLst/>
-          </a:prstGeom>
-        </p:spPr>
-      </p:pic>
-      <p:sp>
-        <p:nvSpPr>
-          <p:cNvPr id="26" name="Shape 22"/>
-          <p:cNvSpPr/>
-          <p:nvPr/>
-        </p:nvSpPr>
-        <p:spPr>
-          <a:xfrm>
-            <a:off x="731520" y="5779008"/>
-            <a:ext cx="118872" cy="118872"/>
+          <p:cNvPr id="30" name="Shape 27"/>
+          <p:cNvSpPr/>
+          <p:nvPr/>
+        </p:nvSpPr>
+        <p:spPr>
+          <a:xfrm>
+            <a:off x="7799832" y="5212080"/>
+            <a:ext cx="100584" cy="100584"/>
           </a:xfrm>
           <a:prstGeom prst="ellipse">
             <a:avLst/>
@@ -11929,30 +12091,30 @@
       </p:sp>
       <p:sp>
         <p:nvSpPr>
-          <p:cNvPr id="27" name="Text 23"/>
-          <p:cNvSpPr txBox="1"/>
-          <p:nvPr/>
-        </p:nvSpPr>
-        <p:spPr>
-          <a:xfrm>
-            <a:off x="969264" y="5687568"/>
-            <a:ext cx="3108960" cy="310896"/>
-          </a:xfrm>
-          <a:prstGeom prst="rect">
-            <a:avLst/>
-          </a:prstGeom>
-          <a:noFill/>
-          <a:ln/>
-        </p:spPr>
-        <p:txBody>
-          <a:bodyPr wrap="square" lIns="0" tIns="0" rIns="0" bIns="0" rtlCol="0" anchor="t"/>
-          <a:lstStyle/>
-          <a:p>
-            <a:pPr indent="0" marL="0">
-              <a:buNone/>
-            </a:pPr>
-            <a:r>
-              <a:rPr lang="en-US" sz="1700" b="1" dirty="0">
+          <p:cNvPr id="31" name="Text 28"/>
+          <p:cNvSpPr txBox="1"/>
+          <p:nvPr/>
+        </p:nvSpPr>
+        <p:spPr>
+          <a:xfrm>
+            <a:off x="8037576" y="5120640"/>
+            <a:ext cx="3419856" cy="292608"/>
+          </a:xfrm>
+          <a:prstGeom prst="rect">
+            <a:avLst/>
+          </a:prstGeom>
+          <a:noFill/>
+          <a:ln/>
+        </p:spPr>
+        <p:txBody>
+          <a:bodyPr wrap="square" lIns="0" tIns="0" rIns="0" bIns="0" rtlCol="0" anchor="t"/>
+          <a:lstStyle/>
+          <a:p>
+            <a:pPr indent="0" marL="0">
+              <a:buNone/>
+            </a:pPr>
+            <a:r>
+              <a:rPr lang="en-US" sz="1500" b="1" dirty="0">
                 <a:solidFill>
                   <a:srgbClr val="143A63"/>
                 </a:solidFill>
@@ -11962,20 +12124,20 @@
               </a:rPr>
               <a:t>중요한 시장 신호를 먼저 확인</a:t>
             </a:r>
-            <a:endParaRPr lang="en-US" sz="1700" dirty="0"/>
-          </a:p>
-        </p:txBody>
-      </p:sp>
-      <p:sp>
-        <p:nvSpPr>
-          <p:cNvPr id="28" name="Shape 24"/>
-          <p:cNvSpPr/>
-          <p:nvPr/>
-        </p:nvSpPr>
-        <p:spPr>
-          <a:xfrm>
-            <a:off x="4443984" y="5779008"/>
-            <a:ext cx="118872" cy="118872"/>
+            <a:endParaRPr lang="en-US" sz="1500" dirty="0"/>
+          </a:p>
+        </p:txBody>
+      </p:sp>
+      <p:sp>
+        <p:nvSpPr>
+          <p:cNvPr id="32" name="Shape 29"/>
+          <p:cNvSpPr/>
+          <p:nvPr/>
+        </p:nvSpPr>
+        <p:spPr>
+          <a:xfrm>
+            <a:off x="7799832" y="5596128"/>
+            <a:ext cx="100584" cy="100584"/>
           </a:xfrm>
           <a:prstGeom prst="ellipse">
             <a:avLst/>
@@ -11993,30 +12155,30 @@
       </p:sp>
       <p:sp>
         <p:nvSpPr>
-          <p:cNvPr id="29" name="Text 25"/>
-          <p:cNvSpPr txBox="1"/>
-          <p:nvPr/>
-        </p:nvSpPr>
-        <p:spPr>
-          <a:xfrm>
-            <a:off x="4681728" y="5687568"/>
-            <a:ext cx="3108960" cy="310896"/>
-          </a:xfrm>
-          <a:prstGeom prst="rect">
-            <a:avLst/>
-          </a:prstGeom>
-          <a:noFill/>
-          <a:ln/>
-        </p:spPr>
-        <p:txBody>
-          <a:bodyPr wrap="square" lIns="0" tIns="0" rIns="0" bIns="0" rtlCol="0" anchor="t"/>
-          <a:lstStyle/>
-          <a:p>
-            <a:pPr indent="0" marL="0">
-              <a:buNone/>
-            </a:pPr>
-            <a:r>
-              <a:rPr lang="en-US" sz="1700" b="1" dirty="0">
+          <p:cNvPr id="33" name="Text 30"/>
+          <p:cNvSpPr txBox="1"/>
+          <p:nvPr/>
+        </p:nvSpPr>
+        <p:spPr>
+          <a:xfrm>
+            <a:off x="8037576" y="5504688"/>
+            <a:ext cx="3419856" cy="292608"/>
+          </a:xfrm>
+          <a:prstGeom prst="rect">
+            <a:avLst/>
+          </a:prstGeom>
+          <a:noFill/>
+          <a:ln/>
+        </p:spPr>
+        <p:txBody>
+          <a:bodyPr wrap="square" lIns="0" tIns="0" rIns="0" bIns="0" rtlCol="0" anchor="t"/>
+          <a:lstStyle/>
+          <a:p>
+            <a:pPr indent="0" marL="0">
+              <a:buNone/>
+            </a:pPr>
+            <a:r>
+              <a:rPr lang="en-US" sz="1500" b="1" dirty="0">
                 <a:solidFill>
                   <a:srgbClr val="143A63"/>
                 </a:solidFill>
@@ -12026,20 +12188,20 @@
               </a:rPr>
               <a:t>AI로 사업 영향과 대응 방향 검토</a:t>
             </a:r>
-            <a:endParaRPr lang="en-US" sz="1700" dirty="0"/>
-          </a:p>
-        </p:txBody>
-      </p:sp>
-      <p:sp>
-        <p:nvSpPr>
-          <p:cNvPr id="30" name="Shape 26"/>
-          <p:cNvSpPr/>
-          <p:nvPr/>
-        </p:nvSpPr>
-        <p:spPr>
-          <a:xfrm>
-            <a:off x="8156448" y="5779008"/>
-            <a:ext cx="118872" cy="118872"/>
+            <a:endParaRPr lang="en-US" sz="1500" dirty="0"/>
+          </a:p>
+        </p:txBody>
+      </p:sp>
+      <p:sp>
+        <p:nvSpPr>
+          <p:cNvPr id="34" name="Shape 31"/>
+          <p:cNvSpPr/>
+          <p:nvPr/>
+        </p:nvSpPr>
+        <p:spPr>
+          <a:xfrm>
+            <a:off x="7799832" y="5980176"/>
+            <a:ext cx="100584" cy="100584"/>
           </a:xfrm>
           <a:prstGeom prst="ellipse">
             <a:avLst/>
@@ -12057,30 +12219,30 @@
       </p:sp>
       <p:sp>
         <p:nvSpPr>
-          <p:cNvPr id="31" name="Text 27"/>
-          <p:cNvSpPr txBox="1"/>
-          <p:nvPr/>
-        </p:nvSpPr>
-        <p:spPr>
-          <a:xfrm>
-            <a:off x="8394192" y="5687568"/>
-            <a:ext cx="3108960" cy="310896"/>
-          </a:xfrm>
-          <a:prstGeom prst="rect">
-            <a:avLst/>
-          </a:prstGeom>
-          <a:noFill/>
-          <a:ln/>
-        </p:spPr>
-        <p:txBody>
-          <a:bodyPr wrap="square" lIns="0" tIns="0" rIns="0" bIns="0" rtlCol="0" anchor="t"/>
-          <a:lstStyle/>
-          <a:p>
-            <a:pPr indent="0" marL="0">
-              <a:buNone/>
-            </a:pPr>
-            <a:r>
-              <a:rPr lang="en-US" sz="1700" b="1" dirty="0">
+          <p:cNvPr id="35" name="Text 32"/>
+          <p:cNvSpPr txBox="1"/>
+          <p:nvPr/>
+        </p:nvSpPr>
+        <p:spPr>
+          <a:xfrm>
+            <a:off x="8037576" y="5888736"/>
+            <a:ext cx="3419856" cy="292608"/>
+          </a:xfrm>
+          <a:prstGeom prst="rect">
+            <a:avLst/>
+          </a:prstGeom>
+          <a:noFill/>
+          <a:ln/>
+        </p:spPr>
+        <p:txBody>
+          <a:bodyPr wrap="square" lIns="0" tIns="0" rIns="0" bIns="0" rtlCol="0" anchor="t"/>
+          <a:lstStyle/>
+          <a:p>
+            <a:pPr indent="0" marL="0">
+              <a:buNone/>
+            </a:pPr>
+            <a:r>
+              <a:rPr lang="en-US" sz="1500" b="1" dirty="0">
                 <a:solidFill>
                   <a:srgbClr val="143A63"/>
                 </a:solidFill>
@@ -12090,7 +12252,7 @@
               </a:rPr>
               <a:t>공시 · 뉴스 원문에서 근거 검증</a:t>
             </a:r>
-            <a:endParaRPr lang="en-US" sz="1700" dirty="0"/>
+            <a:endParaRPr lang="en-US" sz="1500" dirty="0"/>
           </a:p>
         </p:txBody>
       </p:sp>

</xml_diff>

<commit_message>
chore: update demo recording to 1-minute sequential walkthrough
Walks the sidebar in its listed order (industry intelligence, financials,
stock, competitor signals, raw materials) rather than jumping around, and
waits for real content to render instead of using fixed delays, so no
panel is captured mid-load.

Raw-material news now appears: the running backend had been serving an
older route shape, and the frontend's per-material news request was
404ing. Closes on a thank-you card matching the deck's styling.

The 7-minute deck embeds the new 60s cut on slide 7.

Co-Authored-By: Claude Opus 5 <noreply@anthropic.com>
</commit_message>
<xml_diff>
--- a/presentation-output/FUTURE_M_RADAR_7분발표.pptx
+++ b/presentation-output/FUTURE_M_RADAR_7분발표.pptx
@@ -1155,10 +1155,10 @@
             <a:r>
               <a:rPr lang="en-US" dirty="0"/>
               <a:t>[발표 목적] 실제 사용 흐름이 '발견 → 해석 → 검증'으로 끊기지 않고 이어짐을 화면으로 보여준다.
-[대본] 실제 동작 화면을 30초 영상으로 준비했습니다. 지금 보시는 것처럼 대시보드에 들어오면 상단에 AI 데일리 브리핑이 오늘 확인할 사안을 먼저 올려줍니다. 아래는 9개사 공시와 뉴스가 한 피드로 모여 있고, 여기서 주요 공시의 AI 분석을 누르면 원문을 파싱해 만든 핵심 요약 세 문장과 계약금액·지분율 같은 핵심 수치, 그리고 사업적 영향 분석이 함께 나옵니다. 경쟁사 신호 히트맵에서는 네 개 축으로 분류한 위험 신호를 한눈에 보고, 재무와 주가, 원자재 가격으로 곧바로 교차 검증할 수 있습니다. 중요한 건 이 발견과 해석과 검증이 한 흐름 안에서 끊기지 않는다는 점입니다.
+[대본] 실제 동작 화면을 30초 영상으로 준비했습니다. 지금 보시는 것처럼 대시보드에 들어오면 상단에 AI 데일리 브리핑이 오늘 확인할 사안을 먼저 올려줍니다. 아래는 9개사 공시와 뉴스가 한 피드로 모여 있고, 여기서 주요 공시의 AI 분석을 누르면 원문을 파싱해 만든 핵심 요약 세 문장과 계약금액·지분율 같은 핵심 수치, 그리고 사업적 영향 분석이 함께 나옵니다. 경쟁사 신호 히트맵에서는 네 개 축으로 분류한 위험 신호를 한눈에 보고, 재무와 주가로 곧바로 교차 검증할 수 있습니다. 마지막 원자재 화면에서는 리튬·니켈·코발트·망간 시세와 함께, 광산·제련·수출입처럼 가격에 직접 영향을 주는 뉴스만 선별해 보여줍니다. 품목을 바꾸면 해당 광물의 뉴스로 즉시 갱신됩니다. 중요한 건 이 발견과 해석과 검증이 한 흐름 안에서 끊기지 않는다는 점입니다.
 [강조할 한 문장] 발견과 해석과 검증이 한 화면 흐름 안에서 끊기지 않는다.
-[예상 시간] 70초 (영상 30초 + 설명)
-[운영 메모] 영상은 슬라이드에 삽입되어 있으며 클릭하면 재생된다. 발표 전 재생 여부를 반드시 사전 점검할 것.
+[예상 시간] 70초 (영상 60초 · 재생 중 설명을 겹쳐 진행)
+[운영 메모] 영상은 슬라이드에 삽입되어 있으며 클릭하면 재생된다. 길이가 60초이므로 영상을 먼저 재생시킨 뒤 재생 중에 설명을 얹는다. 발표 전 재생 여부를 반드시 사전 점검할 것.
 [출처] 영상은 본 프로젝트에서 직접 개발한 FUTURE:M RADAR 실행 화면을 녹화한 것이다.
 [다음 연결] 마지막으로 기대 효과와 이 과정에서 배운 점을 말씀드리겠습니다.</a:t>
             </a:r>
@@ -11377,7 +11377,7 @@
                 <a:ea typeface="함초롬돋움" pitchFamily="34" charset="-122"/>
                 <a:cs typeface="함초롬돋움" pitchFamily="34" charset="-120"/>
               </a:rPr>
-              <a:t>실제 화면 시연 · 30초 (재생 버튼을 눌러 시작)</a:t>
+              <a:t>실제 화면 시연 · 1분 (재생 버튼을 눌러 시작)</a:t>
             </a:r>
             <a:endParaRPr lang="en-US" sz="1350" dirty="0"/>
           </a:p>
@@ -11521,7 +11521,7 @@
                 <a:ea typeface="함초롬돋움" pitchFamily="34" charset="-122"/>
                 <a:cs typeface="함초롬돋움" pitchFamily="34" charset="-120"/>
               </a:rPr>
-              <a:t>모니터링 기업 선택</a:t>
+              <a:t>산업 인텔리전스</a:t>
             </a:r>
             <a:endParaRPr lang="en-US" sz="1450" dirty="0"/>
           </a:p>
@@ -11649,7 +11649,7 @@
                 <a:ea typeface="함초롬돋움" pitchFamily="34" charset="-122"/>
                 <a:cs typeface="함초롬돋움" pitchFamily="34" charset="-120"/>
               </a:rPr>
-              <a:t>공시 · 뉴스 확인</a:t>
+              <a:t>기업 재무분석</a:t>
             </a:r>
             <a:endParaRPr lang="en-US" sz="1450" dirty="0"/>
           </a:p>
@@ -11777,7 +11777,7 @@
                 <a:ea typeface="함초롬돋움" pitchFamily="34" charset="-122"/>
                 <a:cs typeface="함초롬돋움" pitchFamily="34" charset="-120"/>
               </a:rPr>
-              <a:t>히트맵에서 위험 확인</a:t>
+              <a:t>주가 분석</a:t>
             </a:r>
             <a:endParaRPr lang="en-US" sz="1450" dirty="0"/>
           </a:p>
@@ -11905,7 +11905,7 @@
                 <a:ea typeface="함초롬돋움" pitchFamily="34" charset="-122"/>
                 <a:cs typeface="함초롬돋움" pitchFamily="34" charset="-120"/>
               </a:rPr>
-              <a:t>AI 임플리케이션 확인</a:t>
+              <a:t>경쟁사 신호</a:t>
             </a:r>
             <a:endParaRPr lang="en-US" sz="1450" dirty="0"/>
           </a:p>
@@ -12033,7 +12033,7 @@
                 <a:ea typeface="함초롬돋움" pitchFamily="34" charset="-122"/>
                 <a:cs typeface="함초롬돋움" pitchFamily="34" charset="-120"/>
               </a:rPr>
-              <a:t>원문에서 근거 검증</a:t>
+              <a:t>원자재 가격</a:t>
             </a:r>
             <a:endParaRPr lang="en-US" sz="1450" dirty="0"/>
           </a:p>

</xml_diff>

<commit_message>
docs: add presentation script and replace slide 3 metric placeholders
The four "[실제 측정값 입력]" slots on slide 3 could not be filled with
measured values, so they are replaced by the qualitative conclusion the
diagram above them actually supports: every stage is stitched together
by hand, so consolidating up to an executive report takes time and the
information loses its timeliness. Speaker notes updated to match.

Also adds a standalone 7-minute presentation script derived from the
deck's speaker notes, with per-slide timing and cumulative budget,
transition lines, a pre-presentation checklist, and prepared answers
for likely Q&A. It corrects the demo-video length noted on slide 7
(30s -> the 60s clip that is actually embedded).

Co-Authored-By: Claude Opus 5 <noreply@anthropic.com>
</commit_message>
<xml_diff>
--- a/presentation-output/FUTURE_M_RADAR_7분발표.pptx
+++ b/presentation-output/FUTURE_M_RADAR_7분발표.pptx
@@ -787,7 +787,7 @@
             <a:r>
               <a:rPr lang="en-US" dirty="0"/>
               <a:t>[발표 목적] 문제의 본질이 정보 부족이 아니라 '분산과 해석 시간'임을 명확히 한다.
-[대본] 기존 방식은 화면과 같습니다. 위쪽 네 단계가 수집인데, DART에서 공시를 보고, 뉴스를 검색하고, 금융 사이트에서 주가와 재무를 확인하고, 원자재 가격을 따로 봅니다. 그 아래가 가공과 판단인데, 흩어진 내용을 다시 정리해 비교하고, 우리 회사에 어떤 영향인지 검토한 다음, 보고자료를 작성합니다. 여기서 문제의 본질은 정보가 부족하다는 게 아니었습니다. 정보는 이미 많습니다. 다만 출처가 흩어져 있고, 수집한 정보가 우리 사업에 어떤 의미인지 판단하는 데 시간이 걸린다는 점이 핵심이었습니다. 아래 수치는 실제 업무 기준으로 측정해 채워 넣을 부분입니다.
+[대본] 기존 방식은 화면과 같습니다. 위쪽 네 단계가 수집인데, DART에서 공시를 보고, 뉴스를 검색하고, 금융 사이트에서 주가와 재무를 확인하고, 원자재 가격을 따로 봅니다. 그 아래가 가공과 판단인데, 흩어진 내용을 다시 정리해 비교하고, 우리 회사에 어떤 영향인지 검토한 다음, 보고자료를 작성합니다. 여기서 문제의 본질은 정보가 부족하다는 게 아니었습니다. 정보는 이미 많습니다. 다만 출처가 흩어져 있고, 수집한 정보가 우리 사업에 어떤 의미인지 판단하는 데 시간이 걸린다는 점이 핵심이었습니다. 그리고 이 모든 단계를 사람이 이어 붙이다 보니, 종합해서 경영진 보고까지 가는 데 시간이 걸리고 그만큼 적시성이 떨어집니다.
 [강조할 한 문장] 문제는 정보 부족이 아니라 분산과 해석에 걸리는 시간이다.
 [예상 시간] 55초
 [다음 연결] 그래서 이 문제를 어떤 관점으로 다시 정의했는지 말씀드리겠습니다.</a:t>
@@ -5843,14 +5843,39 @@
       </p:sp>
       <p:sp>
         <p:nvSpPr>
-          <p:cNvPr id="39" name="Text 37"/>
-          <p:cNvSpPr txBox="1"/>
-          <p:nvPr/>
-        </p:nvSpPr>
-        <p:spPr>
-          <a:xfrm>
-            <a:off x="1060704" y="5358384"/>
-            <a:ext cx="2468880" cy="256032"/>
+          <p:cNvPr id="39" name="Shape 37"/>
+          <p:cNvSpPr/>
+          <p:nvPr/>
+        </p:nvSpPr>
+        <p:spPr>
+          <a:xfrm>
+            <a:off x="1060704" y="5394960"/>
+            <a:ext cx="54864" cy="530352"/>
+          </a:xfrm>
+          <a:prstGeom prst="rect">
+            <a:avLst/>
+          </a:prstGeom>
+          <a:solidFill>
+            <a:srgbClr val="00A88F"/>
+          </a:solidFill>
+          <a:ln w="12700">
+            <a:solidFill>
+              <a:srgbClr val="333333"/>
+            </a:solidFill>
+            <a:prstDash val="solid"/>
+          </a:ln>
+        </p:spPr>
+      </p:sp>
+      <p:sp>
+        <p:nvSpPr>
+          <p:cNvPr id="40" name="Text 38"/>
+          <p:cNvSpPr txBox="1"/>
+          <p:nvPr/>
+        </p:nvSpPr>
+        <p:spPr>
+          <a:xfrm>
+            <a:off x="1261872" y="5376672"/>
+            <a:ext cx="4572000" cy="237744"/>
           </a:xfrm>
           <a:prstGeom prst="rect">
             <a:avLst/>
@@ -5868,13 +5893,13 @@
             <a:r>
               <a:rPr lang="en-US" sz="1400" dirty="0">
                 <a:solidFill>
-                  <a:srgbClr val="738BA3"/>
-                </a:solidFill>
-                <a:latin typeface="함초롬돋움" pitchFamily="34" charset="0"/>
-                <a:ea typeface="함초롬돋움" pitchFamily="34" charset="-122"/>
-                <a:cs typeface="함초롬돋움" pitchFamily="34" charset="-120"/>
-              </a:rPr>
-              <a:t>확인 대상 기업</a:t>
+                  <a:srgbClr val="4FD1BC"/>
+                </a:solidFill>
+                <a:latin typeface="함초롬돋움" pitchFamily="34" charset="0"/>
+                <a:ea typeface="함초롬돋움" pitchFamily="34" charset="-122"/>
+                <a:cs typeface="함초롬돋움" pitchFamily="34" charset="-120"/>
+              </a:rPr>
+              <a:t>수집 · 정리 · 해석 · 보고까지</a:t>
             </a:r>
             <a:endParaRPr lang="en-US" sz="1400" dirty="0"/>
           </a:p>
@@ -5882,14 +5907,14 @@
       </p:sp>
       <p:sp>
         <p:nvSpPr>
-          <p:cNvPr id="40" name="Text 38"/>
-          <p:cNvSpPr txBox="1"/>
-          <p:nvPr/>
-        </p:nvSpPr>
-        <p:spPr>
-          <a:xfrm>
-            <a:off x="1060704" y="5650992"/>
-            <a:ext cx="2514600" cy="292608"/>
+          <p:cNvPr id="41" name="Text 39"/>
+          <p:cNvSpPr txBox="1"/>
+          <p:nvPr/>
+        </p:nvSpPr>
+        <p:spPr>
+          <a:xfrm>
+            <a:off x="1261872" y="5632704"/>
+            <a:ext cx="9326880" cy="310896"/>
           </a:xfrm>
           <a:prstGeom prst="rect">
             <a:avLst/>
@@ -5907,247 +5932,13 @@
             <a:r>
               <a:rPr lang="en-US" sz="1700" b="1" dirty="0">
                 <a:solidFill>
-                  <a:srgbClr val="4FD1BC"/>
-                </a:solidFill>
-                <a:latin typeface="함초롬돋움" pitchFamily="34" charset="0"/>
-                <a:ea typeface="함초롬돋움" pitchFamily="34" charset="-122"/>
-                <a:cs typeface="함초롬돋움" pitchFamily="34" charset="-120"/>
-              </a:rPr>
-              <a:t>[실제 측정값 입력]</a:t>
-            </a:r>
-            <a:endParaRPr lang="en-US" sz="1700" dirty="0"/>
-          </a:p>
-        </p:txBody>
-      </p:sp>
-      <p:sp>
-        <p:nvSpPr>
-          <p:cNvPr id="41" name="Text 39"/>
-          <p:cNvSpPr txBox="1"/>
-          <p:nvPr/>
-        </p:nvSpPr>
-        <p:spPr>
-          <a:xfrm>
-            <a:off x="3675888" y="5358384"/>
-            <a:ext cx="2468880" cy="256032"/>
-          </a:xfrm>
-          <a:prstGeom prst="rect">
-            <a:avLst/>
-          </a:prstGeom>
-          <a:noFill/>
-          <a:ln/>
-        </p:spPr>
-        <p:txBody>
-          <a:bodyPr wrap="square" lIns="0" tIns="0" rIns="0" bIns="0" rtlCol="0" anchor="t"/>
-          <a:lstStyle/>
-          <a:p>
-            <a:pPr indent="0" marL="0">
-              <a:buNone/>
-            </a:pPr>
-            <a:r>
-              <a:rPr lang="en-US" sz="1400" dirty="0">
-                <a:solidFill>
-                  <a:srgbClr val="738BA3"/>
-                </a:solidFill>
-                <a:latin typeface="함초롬돋움" pitchFamily="34" charset="0"/>
-                <a:ea typeface="함초롬돋움" pitchFamily="34" charset="-122"/>
-                <a:cs typeface="함초롬돋움" pitchFamily="34" charset="-120"/>
-              </a:rPr>
-              <a:t>방문하는 사이트 수</a:t>
-            </a:r>
-            <a:endParaRPr lang="en-US" sz="1400" dirty="0"/>
-          </a:p>
-        </p:txBody>
-      </p:sp>
-      <p:sp>
-        <p:nvSpPr>
-          <p:cNvPr id="42" name="Text 40"/>
-          <p:cNvSpPr txBox="1"/>
-          <p:nvPr/>
-        </p:nvSpPr>
-        <p:spPr>
-          <a:xfrm>
-            <a:off x="3675888" y="5650992"/>
-            <a:ext cx="2514600" cy="292608"/>
-          </a:xfrm>
-          <a:prstGeom prst="rect">
-            <a:avLst/>
-          </a:prstGeom>
-          <a:noFill/>
-          <a:ln/>
-        </p:spPr>
-        <p:txBody>
-          <a:bodyPr wrap="square" lIns="0" tIns="0" rIns="0" bIns="0" rtlCol="0" anchor="t"/>
-          <a:lstStyle/>
-          <a:p>
-            <a:pPr indent="0" marL="0">
-              <a:buNone/>
-            </a:pPr>
-            <a:r>
-              <a:rPr lang="en-US" sz="1700" b="1" dirty="0">
-                <a:solidFill>
-                  <a:srgbClr val="4FD1BC"/>
-                </a:solidFill>
-                <a:latin typeface="함초롬돋움" pitchFamily="34" charset="0"/>
-                <a:ea typeface="함초롬돋움" pitchFamily="34" charset="-122"/>
-                <a:cs typeface="함초롬돋움" pitchFamily="34" charset="-120"/>
-              </a:rPr>
-              <a:t>[실제 측정값 입력]</a:t>
-            </a:r>
-            <a:endParaRPr lang="en-US" sz="1700" dirty="0"/>
-          </a:p>
-        </p:txBody>
-      </p:sp>
-      <p:sp>
-        <p:nvSpPr>
-          <p:cNvPr id="43" name="Text 41"/>
-          <p:cNvSpPr txBox="1"/>
-          <p:nvPr/>
-        </p:nvSpPr>
-        <p:spPr>
-          <a:xfrm>
-            <a:off x="6291072" y="5358384"/>
-            <a:ext cx="2468880" cy="256032"/>
-          </a:xfrm>
-          <a:prstGeom prst="rect">
-            <a:avLst/>
-          </a:prstGeom>
-          <a:noFill/>
-          <a:ln/>
-        </p:spPr>
-        <p:txBody>
-          <a:bodyPr wrap="square" lIns="0" tIns="0" rIns="0" bIns="0" rtlCol="0" anchor="t"/>
-          <a:lstStyle/>
-          <a:p>
-            <a:pPr indent="0" marL="0">
-              <a:buNone/>
-            </a:pPr>
-            <a:r>
-              <a:rPr lang="en-US" sz="1400" dirty="0">
-                <a:solidFill>
-                  <a:srgbClr val="738BA3"/>
-                </a:solidFill>
-                <a:latin typeface="함초롬돋움" pitchFamily="34" charset="0"/>
-                <a:ea typeface="함초롬돋움" pitchFamily="34" charset="-122"/>
-                <a:cs typeface="함초롬돋움" pitchFamily="34" charset="-120"/>
-              </a:rPr>
-              <a:t>1회 정보 수집 시간</a:t>
-            </a:r>
-            <a:endParaRPr lang="en-US" sz="1400" dirty="0"/>
-          </a:p>
-        </p:txBody>
-      </p:sp>
-      <p:sp>
-        <p:nvSpPr>
-          <p:cNvPr id="44" name="Text 42"/>
-          <p:cNvSpPr txBox="1"/>
-          <p:nvPr/>
-        </p:nvSpPr>
-        <p:spPr>
-          <a:xfrm>
-            <a:off x="6291072" y="5650992"/>
-            <a:ext cx="2514600" cy="292608"/>
-          </a:xfrm>
-          <a:prstGeom prst="rect">
-            <a:avLst/>
-          </a:prstGeom>
-          <a:noFill/>
-          <a:ln/>
-        </p:spPr>
-        <p:txBody>
-          <a:bodyPr wrap="square" lIns="0" tIns="0" rIns="0" bIns="0" rtlCol="0" anchor="t"/>
-          <a:lstStyle/>
-          <a:p>
-            <a:pPr indent="0" marL="0">
-              <a:buNone/>
-            </a:pPr>
-            <a:r>
-              <a:rPr lang="en-US" sz="1700" b="1" dirty="0">
-                <a:solidFill>
-                  <a:srgbClr val="4FD1BC"/>
-                </a:solidFill>
-                <a:latin typeface="함초롬돋움" pitchFamily="34" charset="0"/>
-                <a:ea typeface="함초롬돋움" pitchFamily="34" charset="-122"/>
-                <a:cs typeface="함초롬돋움" pitchFamily="34" charset="-120"/>
-              </a:rPr>
-              <a:t>[실제 측정값 입력]</a:t>
-            </a:r>
-            <a:endParaRPr lang="en-US" sz="1700" dirty="0"/>
-          </a:p>
-        </p:txBody>
-      </p:sp>
-      <p:sp>
-        <p:nvSpPr>
-          <p:cNvPr id="45" name="Text 43"/>
-          <p:cNvSpPr txBox="1"/>
-          <p:nvPr/>
-        </p:nvSpPr>
-        <p:spPr>
-          <a:xfrm>
-            <a:off x="8906256" y="5358384"/>
-            <a:ext cx="2468880" cy="256032"/>
-          </a:xfrm>
-          <a:prstGeom prst="rect">
-            <a:avLst/>
-          </a:prstGeom>
-          <a:noFill/>
-          <a:ln/>
-        </p:spPr>
-        <p:txBody>
-          <a:bodyPr wrap="square" lIns="0" tIns="0" rIns="0" bIns="0" rtlCol="0" anchor="t"/>
-          <a:lstStyle/>
-          <a:p>
-            <a:pPr indent="0" marL="0">
-              <a:buNone/>
-            </a:pPr>
-            <a:r>
-              <a:rPr lang="en-US" sz="1400" dirty="0">
-                <a:solidFill>
-                  <a:srgbClr val="738BA3"/>
-                </a:solidFill>
-                <a:latin typeface="함초롬돋움" pitchFamily="34" charset="0"/>
-                <a:ea typeface="함초롬돋움" pitchFamily="34" charset="-122"/>
-                <a:cs typeface="함초롬돋움" pitchFamily="34" charset="-120"/>
-              </a:rPr>
-              <a:t>보고자료 작성 시간</a:t>
-            </a:r>
-            <a:endParaRPr lang="en-US" sz="1400" dirty="0"/>
-          </a:p>
-        </p:txBody>
-      </p:sp>
-      <p:sp>
-        <p:nvSpPr>
-          <p:cNvPr id="46" name="Text 44"/>
-          <p:cNvSpPr txBox="1"/>
-          <p:nvPr/>
-        </p:nvSpPr>
-        <p:spPr>
-          <a:xfrm>
-            <a:off x="8906256" y="5650992"/>
-            <a:ext cx="2514600" cy="292608"/>
-          </a:xfrm>
-          <a:prstGeom prst="rect">
-            <a:avLst/>
-          </a:prstGeom>
-          <a:noFill/>
-          <a:ln/>
-        </p:spPr>
-        <p:txBody>
-          <a:bodyPr wrap="square" lIns="0" tIns="0" rIns="0" bIns="0" rtlCol="0" anchor="t"/>
-          <a:lstStyle/>
-          <a:p>
-            <a:pPr indent="0" marL="0">
-              <a:buNone/>
-            </a:pPr>
-            <a:r>
-              <a:rPr lang="en-US" sz="1700" b="1" dirty="0">
-                <a:solidFill>
-                  <a:srgbClr val="4FD1BC"/>
-                </a:solidFill>
-                <a:latin typeface="함초롬돋움" pitchFamily="34" charset="0"/>
-                <a:ea typeface="함초롬돋움" pitchFamily="34" charset="-122"/>
-                <a:cs typeface="함초롬돋움" pitchFamily="34" charset="-120"/>
-              </a:rPr>
-              <a:t>[실제 측정값 입력]</a:t>
+                  <a:srgbClr val="FFFFFF"/>
+                </a:solidFill>
+                <a:latin typeface="함초롬돋움" pitchFamily="34" charset="0"/>
+                <a:ea typeface="함초롬돋움" pitchFamily="34" charset="-122"/>
+                <a:cs typeface="함초롬돋움" pitchFamily="34" charset="-120"/>
+              </a:rPr>
+              <a:t>모든 단계를 사람이 이어 붙이는 구조여서 종합에 시간이 걸리고, 그만큼 적시성이 떨어집니다</a:t>
             </a:r>
             <a:endParaRPr lang="en-US" sz="1700" dirty="0"/>
           </a:p>

</xml_diff>